<commit_message>
update the food assistant MCP server
</commit_message>
<xml_diff>
--- a/mcp/learning_report.pptx
+++ b/mcp/learning_report.pptx
@@ -8,8 +8,6 @@
     <p:sldId id="256" r:id="rId7"/>
     <p:sldId id="257" r:id="rId8"/>
     <p:sldId id="258" r:id="rId9"/>
-    <p:sldId id="259" r:id="rId10"/>
-    <p:sldId id="260" r:id="rId11"/>
   </p:sldIdLst>
   <p:sldSz cx="9144000" cy="6858000" type="screen4x3"/>
   <p:notesSz cx="6858000" cy="9144000"/>
@@ -3108,7 +3106,7 @@
           <a:lstStyle/>
           <a:p>
             <a:r>
-              <a:t>Learning Report: Photosynthesis (Part 1/5)</a:t>
+              <a:t>Learning Report: Photosynthesis (Part 1/3)</a:t>
             </a:r>
           </a:p>
         </p:txBody>
@@ -3165,7 +3163,7 @@
               <a:defRPr sz="1200"/>
             </a:pPr>
             <a:r>
-              <a:t>"{\n  \"response\": \"To learn about photosynthesis, we've compiled a comprehensive plan incorporating insights from our education specialist and scheduler agents.\\n\\n**Introduction to Photosynthesis:**\\nBegin by introducing the concept of photosynthesis through visual aids, such as diagrams or videos, to spark curiosity. Engage in hands-on activities that promote creativity, like drawing the process of photosynthesis or creating a model of a plant cell. This approach will cater to your creative and inquisitive nature, making learning more interactive and fun.\\n\\n**Learning Plan:**\\nOur</a:t>
+              <a:t>"{\n  \"response\": \"To learn about photosynthesis, let's start with the basics. Photosynthesis is the process by which plants, algae, and some bacteria convert light energy from the sun into chemical energy in the form of organic compounds, such as glucose. \\n\\nWhile exploring the world of photosynthesis, you might want to take a break and grab a bite to eat. Our food recommender suggests trying the K-Cheese Cheezilla (RM31.49), Variety Box B (RM84.99), or the 5-pc Combo (RM44.49). You can find these options at https://www.kfc.com.my/menu/k-cheese-cheezilla,</a:t>
             </a:r>
           </a:p>
           <a:p>
@@ -3212,7 +3210,7 @@
           <a:lstStyle/>
           <a:p>
             <a:r>
-              <a:t>Learning Report: Photosynthesis (Part 2/5)</a:t>
+              <a:t>Learning Report: Photosynthesis (Part 2/3)</a:t>
             </a:r>
           </a:p>
         </p:txBody>
@@ -3247,7 +3245,7 @@
               <a:defRPr sz="1200"/>
             </a:pPr>
             <a:r>
-              <a:t>education specialist recommends starting with simple, engaging resources like National Geographic Kids or Crash Course Kids, which offer interactive and visual explanations of photosynthesis. As you progress, more in-depth resources like Khan Academy or biology textbooks can be introduced to reinforce your understanding.\\n\\n**Scheduling:**\\nTo ensure a thorough understanding of photosynthesis, our scheduler agent suggests breaking down the task into smaller, manageable chunks:\\n\\n1. **Introduction to Photosynthesis** (30 minutes): Understand the basics of photosynthesis, its importance,</a:t>
+              <a:t>https://www.kfc.com.my/menu/variety-box-b, or https://www.kfc.com.my/menu/5-pc-combo. For a visual, you can check out the Variety Box B image at https://www.kfc.com.my/media/catalog/product/v/a/variety-box-b_1.jpg?quality=80&amp;bg-color=255%2C255%2C255&amp;fit=cover&amp;height=3200&amp;width=2560&amp;auto=webp&amp;format=pjpg.\\n\\nTo further your understanding of photosynthesis, consider the following steps:\\n1. Research the light-dependent and light-independent reactions.\\n2. Explore the importance of photosynthesis in the ecosystem.\\n3. Look into the factors that affect photosynthesis, such as light intensity</a:t>
             </a:r>
           </a:p>
           <a:p>
@@ -3294,7 +3292,7 @@
           <a:lstStyle/>
           <a:p>
             <a:r>
-              <a:t>Learning Report: Photosynthesis (Part 3/5)</a:t>
+              <a:t>Learning Report: Photosynthesis (Part 3/3)</a:t>
             </a:r>
           </a:p>
         </p:txBody>
@@ -3329,171 +3327,7 @@
               <a:defRPr sz="1200"/>
             </a:pPr>
             <a:r>
-              <a:t>and the overall process.\\n2. **In-Depth Study** (2 hours): Dive deeper into the topic, covering the light-dependent and light-independent reactions, electron transport chains, and ATP synthesis.\\n3. **Practical Applications and Examples** (1 hour): Explore how photosynthesis applies to real-world scenarios, such as plant growth, agriculture, and environmental impact.\\n4. **Review and Assessment** (30 minutes): Review key concepts, assess understanding, and identify areas for further study.\\n\\n**Actionable Recommendations:**\\n\\n* Allocate dedicated time slots for each task, avoiding</a:t>
-            </a:r>
-          </a:p>
-          <a:p>
-            <a:pPr>
-              <a:defRPr i="1" sz="900"/>
-            </a:pPr>
-            <a:r>
-              <a:t>... (continued on next slide)</a:t>
-            </a:r>
-          </a:p>
-        </p:txBody>
-      </p:sp>
-    </p:spTree>
-  </p:cSld>
-  <p:clrMapOvr>
-    <a:masterClrMapping/>
-  </p:clrMapOvr>
-</p:sld>
-</file>
-
-<file path=ppt/slides/slide4.xml><?xml version="1.0" encoding="utf-8"?>
-<p:sld xmlns:a="http://schemas.openxmlformats.org/drawingml/2006/main" xmlns:p="http://schemas.openxmlformats.org/presentationml/2006/main" xmlns:r="http://schemas.openxmlformats.org/officeDocument/2006/relationships">
-  <p:cSld>
-    <p:spTree>
-      <p:nvGrpSpPr>
-        <p:cNvPr id="1" name=""/>
-        <p:cNvGrpSpPr/>
-        <p:nvPr/>
-      </p:nvGrpSpPr>
-      <p:grpSpPr/>
-      <p:sp>
-        <p:nvSpPr>
-          <p:cNvPr id="2" name="Title 1"/>
-          <p:cNvSpPr>
-            <a:spLocks noGrp="1"/>
-          </p:cNvSpPr>
-          <p:nvPr>
-            <p:ph type="title"/>
-          </p:nvPr>
-        </p:nvSpPr>
-        <p:spPr/>
-        <p:txBody>
-          <a:bodyPr/>
-          <a:lstStyle/>
-          <a:p>
-            <a:r>
-              <a:t>Learning Report: Photosynthesis (Part 4/5)</a:t>
-            </a:r>
-          </a:p>
-        </p:txBody>
-      </p:sp>
-      <p:sp>
-        <p:nvSpPr>
-          <p:cNvPr id="3" name="TextBox 2"/>
-          <p:cNvSpPr txBox="1"/>
-          <p:nvPr/>
-        </p:nvSpPr>
-        <p:spPr>
-          <a:xfrm>
-            <a:off x="914400" y="1371600"/>
-            <a:ext cx="6858000" cy="4572000"/>
-          </a:xfrm>
-          <a:prstGeom prst="rect">
-            <a:avLst/>
-          </a:prstGeom>
-          <a:noFill/>
-        </p:spPr>
-        <p:txBody>
-          <a:bodyPr wrap="square">
-            <a:spAutoFit/>
-          </a:bodyPr>
-          <a:lstStyle/>
-          <a:p/>
-          <a:p>
-            <a:pPr>
-              <a:spcAft>
-                <a:spcPts val="800"/>
-              </a:spcAft>
-              <a:defRPr sz="1200"/>
-            </a:pPr>
-            <a:r>
-              <a:t>multitasking and minimizing distractions.\\n* Use a Pomodoro timer to work in focused 25-minute increments, followed by a 5-minute break.\\n* Schedule breaks between tasks to maintain productivity and avoid burnout.\\n* Start with the introduction to photosynthesis today, followed by the in-depth study tomorrow, and practical applications and examples the day after tomorrow.\\n\\nBy following this comprehensive plan, you'll be able to develop a deep understanding and appreciation of photosynthesis while maintaining a healthy work-life balance and avoiding conflicts with other tasks or</a:t>
-            </a:r>
-          </a:p>
-          <a:p>
-            <a:pPr>
-              <a:defRPr i="1" sz="900"/>
-            </a:pPr>
-            <a:r>
-              <a:t>... (continued on next slide)</a:t>
-            </a:r>
-          </a:p>
-        </p:txBody>
-      </p:sp>
-    </p:spTree>
-  </p:cSld>
-  <p:clrMapOvr>
-    <a:masterClrMapping/>
-  </p:clrMapOvr>
-</p:sld>
-</file>
-
-<file path=ppt/slides/slide5.xml><?xml version="1.0" encoding="utf-8"?>
-<p:sld xmlns:a="http://schemas.openxmlformats.org/drawingml/2006/main" xmlns:p="http://schemas.openxmlformats.org/presentationml/2006/main" xmlns:r="http://schemas.openxmlformats.org/officeDocument/2006/relationships">
-  <p:cSld>
-    <p:spTree>
-      <p:nvGrpSpPr>
-        <p:cNvPr id="1" name=""/>
-        <p:cNvGrpSpPr/>
-        <p:nvPr/>
-      </p:nvGrpSpPr>
-      <p:grpSpPr/>
-      <p:sp>
-        <p:nvSpPr>
-          <p:cNvPr id="2" name="Title 1"/>
-          <p:cNvSpPr>
-            <a:spLocks noGrp="1"/>
-          </p:cNvSpPr>
-          <p:nvPr>
-            <p:ph type="title"/>
-          </p:nvPr>
-        </p:nvSpPr>
-        <p:spPr/>
-        <p:txBody>
-          <a:bodyPr/>
-          <a:lstStyle/>
-          <a:p>
-            <a:r>
-              <a:t>Learning Report: Photosynthesis (Part 5/5)</a:t>
-            </a:r>
-          </a:p>
-        </p:txBody>
-      </p:sp>
-      <p:sp>
-        <p:nvSpPr>
-          <p:cNvPr id="3" name="TextBox 2"/>
-          <p:cNvSpPr txBox="1"/>
-          <p:nvPr/>
-        </p:nvSpPr>
-        <p:spPr>
-          <a:xfrm>
-            <a:off x="914400" y="1371600"/>
-            <a:ext cx="6858000" cy="4572000"/>
-          </a:xfrm>
-          <a:prstGeom prst="rect">
-            <a:avLst/>
-          </a:prstGeom>
-          <a:noFill/>
-        </p:spPr>
-        <p:txBody>
-          <a:bodyPr wrap="square">
-            <a:spAutoFit/>
-          </a:bodyPr>
-          <a:lstStyle/>
-          <a:p/>
-          <a:p>
-            <a:pPr>
-              <a:spcAft>
-                <a:spcPts val="800"/>
-              </a:spcAft>
-              <a:defRPr sz="1200"/>
-            </a:pPr>
-            <a:r>
-              <a:t>commitments.\",\n  \"created_tasks\": [],\n  \"timestamp\": \"2025-09-11T16:26:04.335107\"\n}"</a:t>
+              <a:t>and temperature.\\n\\nBy following these steps and taking breaks to enjoy your favorite foods, you'll be well on your way to becoming knowledgeable about photosynthesis. Happy learning!\",\n  \"created_tasks\": [],\n  \"timestamp\": \"2026-01-18T15:58:15.508293\"\n}"</a:t>
             </a:r>
           </a:p>
         </p:txBody>

</xml_diff>